<commit_message>
Improve humaneval answer visibility and citation wording
</commit_message>
<xml_diff>
--- a/slides/datasets-in-10-minutes-humaneval.pptx
+++ b/slides/datasets-in-10-minutes-humaneval.pptx
@@ -12763,7 +12763,7 @@
                 <a:ea typeface="Noto Sans CJK JP"/>
                 <a:cs typeface="Noto Sans"/>
               </a:rPr>
-              <a:t>Chenら（2021）のTable 1。各指標には論文が選んだ生成温度を使う。12Bは約120億パラメータ。</a:t>
+              <a:t>各指標には論文が選んだ生成温度を使う。12Bは約120億パラメータ。</a:t>
             </a:r>
           </a:p>
         </p:txBody>
@@ -13892,7 +13892,7 @@
                 <a:ea typeface="Noto Sans CJK JP"/>
                 <a:cs typeface="Noto Sans"/>
               </a:rPr>
-              <a:t>Qwen2.5-Coder報告Table 16のpass@1。HumanEval+はテストを拡充した同じ164問。</a:t>
+              <a:t>pass@1。HumanEval+はテストを拡充した同じ164問。</a:t>
             </a:r>
           </a:p>
         </p:txBody>

</xml_diff>